<commit_message>
Polish repository evidence and automation
</commit_message>
<xml_diff>
--- a/KisanFlow_Presentation.pptx
+++ b/KisanFlow_Presentation.pptx
@@ -2,22 +2,22 @@
 <file path=ppt/presentation.xml><?xml version="1.0" encoding="utf-8"?>
 <p:presentation xmlns:p="http://schemas.openxmlformats.org/presentationml/2006/main">
   <p:sldMasterIdLst>
-    <p:sldMasterId xmlns:r="http://schemas.openxmlformats.org/officeDocument/2006/relationships" id="2147483648" r:id="R81d1b7349165490c"/>
+    <p:sldMasterId xmlns:r="http://schemas.openxmlformats.org/officeDocument/2006/relationships" id="2147483648" r:id="R9fe9a8b4677e4ee2"/>
   </p:sldMasterIdLst>
   <p:notesMasterIdLst>
-    <p:notesMasterId xmlns:r="http://schemas.openxmlformats.org/officeDocument/2006/relationships" r:id="Ra9e7a9aa9b2f49e4"/>
+    <p:notesMasterId xmlns:r="http://schemas.openxmlformats.org/officeDocument/2006/relationships" r:id="R5ddce4a4560d423b"/>
   </p:notesMasterIdLst>
   <p:sldIdLst>
-    <p:sldId xmlns:r="http://schemas.openxmlformats.org/officeDocument/2006/relationships" id="256" r:id="Rdf619b4b21654d15"/>
-    <p:sldId xmlns:r="http://schemas.openxmlformats.org/officeDocument/2006/relationships" id="257" r:id="R7216ffb22c5847dd"/>
-    <p:sldId xmlns:r="http://schemas.openxmlformats.org/officeDocument/2006/relationships" id="258" r:id="Ra4537b98f8dd4b30"/>
-    <p:sldId xmlns:r="http://schemas.openxmlformats.org/officeDocument/2006/relationships" id="259" r:id="R9e2a3d6247154eb6"/>
-    <p:sldId xmlns:r="http://schemas.openxmlformats.org/officeDocument/2006/relationships" id="260" r:id="R60f6623fa5594d7a"/>
-    <p:sldId xmlns:r="http://schemas.openxmlformats.org/officeDocument/2006/relationships" id="261" r:id="Rba2117ab253942d0"/>
-    <p:sldId xmlns:r="http://schemas.openxmlformats.org/officeDocument/2006/relationships" id="262" r:id="R75df2bdcbca744ce"/>
-    <p:sldId xmlns:r="http://schemas.openxmlformats.org/officeDocument/2006/relationships" id="263" r:id="Raa038a740995402a"/>
-    <p:sldId xmlns:r="http://schemas.openxmlformats.org/officeDocument/2006/relationships" id="264" r:id="Rb3f78c216efe48da"/>
-    <p:sldId xmlns:r="http://schemas.openxmlformats.org/officeDocument/2006/relationships" id="265" r:id="R45276e1d05a94769"/>
+    <p:sldId xmlns:r="http://schemas.openxmlformats.org/officeDocument/2006/relationships" id="256" r:id="R11d464bbbad94ce6"/>
+    <p:sldId xmlns:r="http://schemas.openxmlformats.org/officeDocument/2006/relationships" id="257" r:id="R42cc41518cfd4d56"/>
+    <p:sldId xmlns:r="http://schemas.openxmlformats.org/officeDocument/2006/relationships" id="258" r:id="R092a9fb7a49648bb"/>
+    <p:sldId xmlns:r="http://schemas.openxmlformats.org/officeDocument/2006/relationships" id="259" r:id="Rb1a92778df4943ed"/>
+    <p:sldId xmlns:r="http://schemas.openxmlformats.org/officeDocument/2006/relationships" id="260" r:id="R4eebd56d295a4d62"/>
+    <p:sldId xmlns:r="http://schemas.openxmlformats.org/officeDocument/2006/relationships" id="261" r:id="Rd501bc932bcb4cf8"/>
+    <p:sldId xmlns:r="http://schemas.openxmlformats.org/officeDocument/2006/relationships" id="262" r:id="R5d504e2325a2479c"/>
+    <p:sldId xmlns:r="http://schemas.openxmlformats.org/officeDocument/2006/relationships" id="263" r:id="R45f5a9d557654cb9"/>
+    <p:sldId xmlns:r="http://schemas.openxmlformats.org/officeDocument/2006/relationships" id="264" r:id="Ree0ff0eaff754f5b"/>
+    <p:sldId xmlns:r="http://schemas.openxmlformats.org/officeDocument/2006/relationships" id="265" r:id="R9922dfc3e99b456a"/>
   </p:sldIdLst>
   <p:sldSz cx="12192000" cy="6858000"/>
   <p:notesSz cx="6858000" cy="9144000"/>
@@ -1311,7 +1311,7 @@
           <a:lstStyle xmlns:a="http://schemas.openxmlformats.org/drawingml/2006/main"/>
           <a:p xmlns:a="http://schemas.openxmlformats.org/drawingml/2006/main">
             <a:r>
-              <a:t>The jury should leave knowing exactly which claims are proven and which are pilot gates.</a:t>
+              <a:t>The audience should leave knowing exactly which claims are proven and which are pilot gates.</a:t>
             </a:r>
             <a:endParaRPr/>
           </a:p>
@@ -1571,9 +1571,9 @@
   </p:cSld>
   <p:clrMap bg1="lt1" tx1="dk1" bg2="lt2" tx2="dk2" accent1="accent1" accent2="accent2" accent3="accent3" accent4="accent4" accent5="accent5" accent6="accent6" hlink="hlink" folHlink="folHlink"/>
   <p:sldLayoutIdLst>
-    <p:sldLayoutId xmlns:r="http://schemas.openxmlformats.org/officeDocument/2006/relationships" id="2147483649" r:id="R8bda7a6873c44c89"/>
-    <p:sldLayoutId xmlns:r="http://schemas.openxmlformats.org/officeDocument/2006/relationships" id="2147483650" r:id="Rba328b75ecd64b64"/>
-    <p:sldLayoutId xmlns:r="http://schemas.openxmlformats.org/officeDocument/2006/relationships" id="2147483651" r:id="R14ce0c65b2514209"/>
+    <p:sldLayoutId xmlns:r="http://schemas.openxmlformats.org/officeDocument/2006/relationships" id="2147483649" r:id="R1d3f5067b7014c9f"/>
+    <p:sldLayoutId xmlns:r="http://schemas.openxmlformats.org/officeDocument/2006/relationships" id="2147483650" r:id="R8eb97477e2094348"/>
+    <p:sldLayoutId xmlns:r="http://schemas.openxmlformats.org/officeDocument/2006/relationships" id="2147483651" r:id="R072d45efe3e84724"/>
   </p:sldLayoutIdLst>
   <p:hf sldNum="0" hdr="0" ftr="0" dt="0"/>
   <p:txStyles>
@@ -2392,7 +2392,7 @@
           <p:nvPr/>
         </p:nvPicPr>
         <p:blipFill>
-          <a:blip xmlns:r="http://schemas.openxmlformats.org/officeDocument/2006/relationships" xmlns:a="http://schemas.openxmlformats.org/drawingml/2006/main" r:embed="Rb9721c6b60434924"/>
+          <a:blip xmlns:r="http://schemas.openxmlformats.org/officeDocument/2006/relationships" xmlns:a="http://schemas.openxmlformats.org/drawingml/2006/main" r:embed="R19d90238cd07461c"/>
           <a:stretch xmlns:a="http://schemas.openxmlformats.org/drawingml/2006/main">
             <a:fillRect l="0" t="0" r="0" b="0"/>
           </a:stretch>
@@ -2493,7 +2493,7 @@
                 <a:ea typeface="Calibri"/>
                 <a:cs typeface="Calibri"/>
               </a:rPr>
-              <a:t>See stress 8 weeks early. Act before a missed repayment.</a:t>
+              <a:t>Anticipate cash-flow stress. Act before a missed repayment.</a:t>
             </a:r>
             <a:endParaRPr sz="2000"/>
           </a:p>
@@ -2612,7 +2612,7 @@
           <p:nvPr/>
         </p:nvPicPr>
         <p:blipFill>
-          <a:blip xmlns:r="http://schemas.openxmlformats.org/officeDocument/2006/relationships" xmlns:a="http://schemas.openxmlformats.org/drawingml/2006/main" r:embed="R08632022daf64704"/>
+          <a:blip xmlns:r="http://schemas.openxmlformats.org/officeDocument/2006/relationships" xmlns:a="http://schemas.openxmlformats.org/drawingml/2006/main" r:embed="Rd83a4b03210e4e8b"/>
           <a:stretch xmlns:a="http://schemas.openxmlformats.org/drawingml/2006/main">
             <a:fillRect l="0" t="0" r="0" b="0"/>
           </a:stretch>
@@ -2731,7 +2731,7 @@
           <p:nvPr/>
         </p:nvPicPr>
         <p:blipFill>
-          <a:blip xmlns:r="http://schemas.openxmlformats.org/officeDocument/2006/relationships" xmlns:a="http://schemas.openxmlformats.org/drawingml/2006/main" r:embed="Rb1a9c67046ca49a4"/>
+          <a:blip xmlns:r="http://schemas.openxmlformats.org/officeDocument/2006/relationships" xmlns:a="http://schemas.openxmlformats.org/drawingml/2006/main" r:embed="Rc7295016fdf24a0b"/>
           <a:stretch xmlns:a="http://schemas.openxmlformats.org/drawingml/2006/main">
             <a:fillRect l="0" t="0" r="0" b="0"/>
           </a:stretch>
@@ -2920,7 +2920,7 @@
           <p:nvPr/>
         </p:nvPicPr>
         <p:blipFill>
-          <a:blip xmlns:r="http://schemas.openxmlformats.org/officeDocument/2006/relationships" xmlns:a="http://schemas.openxmlformats.org/drawingml/2006/main" r:embed="R50445f31637141be"/>
+          <a:blip xmlns:r="http://schemas.openxmlformats.org/officeDocument/2006/relationships" xmlns:a="http://schemas.openxmlformats.org/drawingml/2006/main" r:embed="Rb08ea33430e84c62"/>
           <a:stretch xmlns:a="http://schemas.openxmlformats.org/drawingml/2006/main">
             <a:fillRect l="0" t="0" r="0" b="0"/>
           </a:stretch>
@@ -3160,7 +3160,7 @@
           <p:nvPr/>
         </p:nvPicPr>
         <p:blipFill>
-          <a:blip xmlns:r="http://schemas.openxmlformats.org/officeDocument/2006/relationships" xmlns:a="http://schemas.openxmlformats.org/drawingml/2006/main" r:embed="Rd564a2ffa7ce4ec0"/>
+          <a:blip xmlns:r="http://schemas.openxmlformats.org/officeDocument/2006/relationships" xmlns:a="http://schemas.openxmlformats.org/drawingml/2006/main" r:embed="Rbd22ddccd9464e97"/>
           <a:stretch xmlns:a="http://schemas.openxmlformats.org/drawingml/2006/main">
             <a:fillRect l="0" t="0" r="0" b="0"/>
           </a:stretch>
@@ -3332,7 +3332,7 @@
           <p:nvPr/>
         </p:nvPicPr>
         <p:blipFill>
-          <a:blip xmlns:r="http://schemas.openxmlformats.org/officeDocument/2006/relationships" xmlns:a="http://schemas.openxmlformats.org/drawingml/2006/main" r:embed="R743e68675b8640e9"/>
+          <a:blip xmlns:r="http://schemas.openxmlformats.org/officeDocument/2006/relationships" xmlns:a="http://schemas.openxmlformats.org/drawingml/2006/main" r:embed="R9ff3f9368d7048b3"/>
           <a:stretch xmlns:a="http://schemas.openxmlformats.org/drawingml/2006/main">
             <a:fillRect l="0" t="0" r="0" b="0"/>
           </a:stretch>
@@ -3504,7 +3504,7 @@
           <p:nvPr/>
         </p:nvPicPr>
         <p:blipFill>
-          <a:blip xmlns:r="http://schemas.openxmlformats.org/officeDocument/2006/relationships" xmlns:a="http://schemas.openxmlformats.org/drawingml/2006/main" r:embed="R55f228c6f0be4c0a"/>
+          <a:blip xmlns:r="http://schemas.openxmlformats.org/officeDocument/2006/relationships" xmlns:a="http://schemas.openxmlformats.org/drawingml/2006/main" r:embed="R3aa43fde0d2a406b"/>
           <a:stretch xmlns:a="http://schemas.openxmlformats.org/drawingml/2006/main">
             <a:fillRect l="0" t="0" r="0" b="0"/>
           </a:stretch>
@@ -3765,7 +3765,7 @@
                 <a:ea typeface="Calibri"/>
                 <a:cs typeface="Calibri"/>
               </a:rPr>
-              <a:t>ONE DEEP JURY CASE</a:t>
+              <a:t>ANCHOR RURAL-FINANCE CASE</a:t>
             </a:r>
             <a:endParaRPr sz="1200"/>
           </a:p>
@@ -3974,7 +3974,7 @@
           <p:nvPr/>
         </p:nvPicPr>
         <p:blipFill>
-          <a:blip xmlns:r="http://schemas.openxmlformats.org/officeDocument/2006/relationships" xmlns:a="http://schemas.openxmlformats.org/drawingml/2006/main" r:embed="Ra5e97487cecc4a9e"/>
+          <a:blip xmlns:r="http://schemas.openxmlformats.org/officeDocument/2006/relationships" xmlns:a="http://schemas.openxmlformats.org/drawingml/2006/main" r:embed="R26d5faeb4eba4f18"/>
           <a:stretch xmlns:a="http://schemas.openxmlformats.org/drawingml/2006/main">
             <a:fillRect l="0" t="0" r="0" b="0"/>
           </a:stretch>
@@ -4132,7 +4132,7 @@
           <p:nvPr/>
         </p:nvPicPr>
         <p:blipFill>
-          <a:blip xmlns:r="http://schemas.openxmlformats.org/officeDocument/2006/relationships" xmlns:a="http://schemas.openxmlformats.org/drawingml/2006/main" r:embed="R2404060ee46848fd"/>
+          <a:blip xmlns:r="http://schemas.openxmlformats.org/officeDocument/2006/relationships" xmlns:a="http://schemas.openxmlformats.org/drawingml/2006/main" r:embed="Re748c845f62944e6"/>
           <a:stretch xmlns:a="http://schemas.openxmlformats.org/drawingml/2006/main">
             <a:fillRect l="0" t="0" r="0" b="0"/>
           </a:stretch>
@@ -4290,7 +4290,7 @@
           <p:nvPr/>
         </p:nvPicPr>
         <p:blipFill>
-          <a:blip xmlns:r="http://schemas.openxmlformats.org/officeDocument/2006/relationships" xmlns:a="http://schemas.openxmlformats.org/drawingml/2006/main" r:embed="R472ed05bc04f4544"/>
+          <a:blip xmlns:r="http://schemas.openxmlformats.org/officeDocument/2006/relationships" xmlns:a="http://schemas.openxmlformats.org/drawingml/2006/main" r:embed="R9b2e4905c4a04ed1"/>
           <a:stretch xmlns:a="http://schemas.openxmlformats.org/drawingml/2006/main">
             <a:fillRect l="0" t="0" r="0" b="0"/>
           </a:stretch>
@@ -4530,7 +4530,7 @@
           <p:nvPr/>
         </p:nvPicPr>
         <p:blipFill>
-          <a:blip xmlns:r="http://schemas.openxmlformats.org/officeDocument/2006/relationships" xmlns:a="http://schemas.openxmlformats.org/drawingml/2006/main" r:embed="R631c08ff8b3741a7"/>
+          <a:blip xmlns:r="http://schemas.openxmlformats.org/officeDocument/2006/relationships" xmlns:a="http://schemas.openxmlformats.org/drawingml/2006/main" r:embed="R05b74204dd894c08"/>
           <a:stretch xmlns:a="http://schemas.openxmlformats.org/drawingml/2006/main">
             <a:fillRect l="0" t="0" r="0" b="0"/>
           </a:stretch>
@@ -4734,7 +4734,7 @@
           <p:nvPr/>
         </p:nvPicPr>
         <p:blipFill>
-          <a:blip xmlns:r="http://schemas.openxmlformats.org/officeDocument/2006/relationships" xmlns:a="http://schemas.openxmlformats.org/drawingml/2006/main" r:embed="Rc5aea17c59de458c"/>
+          <a:blip xmlns:r="http://schemas.openxmlformats.org/officeDocument/2006/relationships" xmlns:a="http://schemas.openxmlformats.org/drawingml/2006/main" r:embed="R3a8a468cc2f34c47"/>
           <a:stretch xmlns:a="http://schemas.openxmlformats.org/drawingml/2006/main">
             <a:fillRect l="0" t="0" r="0" b="0"/>
           </a:stretch>
@@ -4938,7 +4938,7 @@
           <p:nvPr/>
         </p:nvPicPr>
         <p:blipFill>
-          <a:blip xmlns:r="http://schemas.openxmlformats.org/officeDocument/2006/relationships" xmlns:a="http://schemas.openxmlformats.org/drawingml/2006/main" r:embed="Rff7a58ce45624b49"/>
+          <a:blip xmlns:r="http://schemas.openxmlformats.org/officeDocument/2006/relationships" xmlns:a="http://schemas.openxmlformats.org/drawingml/2006/main" r:embed="R7ad7c9e44875421b"/>
           <a:stretch xmlns:a="http://schemas.openxmlformats.org/drawingml/2006/main">
             <a:fillRect l="0" t="0" r="0" b="0"/>
           </a:stretch>
@@ -5142,7 +5142,7 @@
           <p:nvPr/>
         </p:nvPicPr>
         <p:blipFill>
-          <a:blip xmlns:r="http://schemas.openxmlformats.org/officeDocument/2006/relationships" xmlns:a="http://schemas.openxmlformats.org/drawingml/2006/main" r:embed="Ree55fbec01814b38"/>
+          <a:blip xmlns:r="http://schemas.openxmlformats.org/officeDocument/2006/relationships" xmlns:a="http://schemas.openxmlformats.org/drawingml/2006/main" r:embed="R76b9fd5584de4651"/>
           <a:stretch xmlns:a="http://schemas.openxmlformats.org/drawingml/2006/main">
             <a:fillRect l="0" t="0" r="0" b="0"/>
           </a:stretch>
@@ -5346,7 +5346,7 @@
           <p:nvPr/>
         </p:nvPicPr>
         <p:blipFill>
-          <a:blip xmlns:r="http://schemas.openxmlformats.org/officeDocument/2006/relationships" xmlns:a="http://schemas.openxmlformats.org/drawingml/2006/main" r:embed="Rcb526c10d5d04f80"/>
+          <a:blip xmlns:r="http://schemas.openxmlformats.org/officeDocument/2006/relationships" xmlns:a="http://schemas.openxmlformats.org/drawingml/2006/main" r:embed="R54574f841d3a408b"/>
           <a:stretch xmlns:a="http://schemas.openxmlformats.org/drawingml/2006/main">
             <a:fillRect l="0" t="0" r="0" b="0"/>
           </a:stretch>
@@ -6200,7 +6200,7 @@
                 <a:ea typeface="Calibri"/>
                 <a:cs typeface="Calibri"/>
               </a:rPr>
-              <a:t>28.2% recall · workload trade-off explicit</a:t>
+              <a:t>28.2% recall · 2-week median lead</a:t>
             </a:r>
             <a:endParaRPr sz="850"/>
           </a:p>
@@ -6477,7 +6477,7 @@
         </p:xfrm>
         <a:graphic xmlns:a="http://schemas.openxmlformats.org/drawingml/2006/main">
           <a:graphicData uri="http://schemas.openxmlformats.org/drawingml/2006/chart">
-            <c:chart xmlns:r="http://schemas.openxmlformats.org/officeDocument/2006/relationships" xmlns:c="http://schemas.openxmlformats.org/drawingml/2006/chart" r:id="Ref4705dd3eef4a29"/>
+            <c:chart xmlns:r="http://schemas.openxmlformats.org/officeDocument/2006/relationships" xmlns:c="http://schemas.openxmlformats.org/drawingml/2006/chart" r:id="R2ef81c17e64642dc"/>
           </a:graphicData>
         </a:graphic>
       </p:graphicFrame>
@@ -6660,7 +6660,7 @@
           <p:nvPr/>
         </p:nvPicPr>
         <p:blipFill>
-          <a:blip xmlns:r="http://schemas.openxmlformats.org/officeDocument/2006/relationships" xmlns:a="http://schemas.openxmlformats.org/drawingml/2006/main" r:embed="R8cbadab8f6604ccc"/>
+          <a:blip xmlns:r="http://schemas.openxmlformats.org/officeDocument/2006/relationships" xmlns:a="http://schemas.openxmlformats.org/drawingml/2006/main" r:embed="R59169372f7d34cd9"/>
           <a:stretch xmlns:a="http://schemas.openxmlformats.org/drawingml/2006/main">
             <a:fillRect l="0" t="0" r="0" b="0"/>
           </a:stretch>
@@ -6864,7 +6864,7 @@
           <p:nvPr/>
         </p:nvPicPr>
         <p:blipFill>
-          <a:blip xmlns:r="http://schemas.openxmlformats.org/officeDocument/2006/relationships" xmlns:a="http://schemas.openxmlformats.org/drawingml/2006/main" r:embed="R42168ca442054072"/>
+          <a:blip xmlns:r="http://schemas.openxmlformats.org/officeDocument/2006/relationships" xmlns:a="http://schemas.openxmlformats.org/drawingml/2006/main" r:embed="R8d50f52fe48d40fb"/>
           <a:stretch xmlns:a="http://schemas.openxmlformats.org/drawingml/2006/main">
             <a:fillRect l="0" t="0" r="0" b="0"/>
           </a:stretch>
@@ -7068,7 +7068,7 @@
           <p:nvPr/>
         </p:nvPicPr>
         <p:blipFill>
-          <a:blip xmlns:r="http://schemas.openxmlformats.org/officeDocument/2006/relationships" xmlns:a="http://schemas.openxmlformats.org/drawingml/2006/main" r:embed="R38d715a8af574c03"/>
+          <a:blip xmlns:r="http://schemas.openxmlformats.org/officeDocument/2006/relationships" xmlns:a="http://schemas.openxmlformats.org/drawingml/2006/main" r:embed="Rf52ffb12165c45a9"/>
           <a:stretch xmlns:a="http://schemas.openxmlformats.org/drawingml/2006/main">
             <a:fillRect l="0" t="0" r="0" b="0"/>
           </a:stretch>
@@ -7272,7 +7272,7 @@
           <p:nvPr/>
         </p:nvPicPr>
         <p:blipFill>
-          <a:blip xmlns:r="http://schemas.openxmlformats.org/officeDocument/2006/relationships" xmlns:a="http://schemas.openxmlformats.org/drawingml/2006/main" r:embed="R50c84f31f5864d7d"/>
+          <a:blip xmlns:r="http://schemas.openxmlformats.org/officeDocument/2006/relationships" xmlns:a="http://schemas.openxmlformats.org/drawingml/2006/main" r:embed="R45cf8a7e6f1d4b6e"/>
           <a:stretch xmlns:a="http://schemas.openxmlformats.org/drawingml/2006/main">
             <a:fillRect l="0" t="0" r="0" b="0"/>
           </a:stretch>
@@ -7476,7 +7476,7 @@
           <p:nvPr/>
         </p:nvPicPr>
         <p:blipFill>
-          <a:blip xmlns:r="http://schemas.openxmlformats.org/officeDocument/2006/relationships" xmlns:a="http://schemas.openxmlformats.org/drawingml/2006/main" r:embed="Rf40d3b1f86a14663"/>
+          <a:blip xmlns:r="http://schemas.openxmlformats.org/officeDocument/2006/relationships" xmlns:a="http://schemas.openxmlformats.org/drawingml/2006/main" r:embed="Rb8300bc704be4dea"/>
           <a:stretch xmlns:a="http://schemas.openxmlformats.org/drawingml/2006/main">
             <a:fillRect l="0" t="0" r="0" b="0"/>
           </a:stretch>
@@ -7691,7 +7691,7 @@
                 <a:ea typeface="Cambria"/>
                 <a:cs typeface="Cambria"/>
               </a:rPr>
-              <a:t>One Case Manager chooses tools; deterministic services own every number</a:t>
+              <a:t>One Case Manager plans; deterministic services own every number</a:t>
             </a:r>
             <a:endParaRPr sz="2600"/>
           </a:p>
@@ -7843,7 +7843,7 @@
           <p:nvPr/>
         </p:nvPicPr>
         <p:blipFill>
-          <a:blip xmlns:r="http://schemas.openxmlformats.org/officeDocument/2006/relationships" xmlns:a="http://schemas.openxmlformats.org/drawingml/2006/main" r:embed="R3d312662282941f1"/>
+          <a:blip xmlns:r="http://schemas.openxmlformats.org/officeDocument/2006/relationships" xmlns:a="http://schemas.openxmlformats.org/drawingml/2006/main" r:embed="R9bcf69a53a904fb8"/>
           <a:stretch xmlns:a="http://schemas.openxmlformats.org/drawingml/2006/main">
             <a:fillRect l="0" t="0" r="0" b="0"/>
           </a:stretch>
@@ -8007,7 +8007,7 @@
           <p:nvPr/>
         </p:nvPicPr>
         <p:blipFill>
-          <a:blip xmlns:r="http://schemas.openxmlformats.org/officeDocument/2006/relationships" xmlns:a="http://schemas.openxmlformats.org/drawingml/2006/main" r:embed="R05269b3afa734741"/>
+          <a:blip xmlns:r="http://schemas.openxmlformats.org/officeDocument/2006/relationships" xmlns:a="http://schemas.openxmlformats.org/drawingml/2006/main" r:embed="Rfa66e5389da541ce"/>
           <a:stretch xmlns:a="http://schemas.openxmlformats.org/drawingml/2006/main">
             <a:fillRect l="0" t="0" r="0" b="0"/>
           </a:stretch>
@@ -8171,7 +8171,7 @@
           <p:nvPr/>
         </p:nvPicPr>
         <p:blipFill>
-          <a:blip xmlns:r="http://schemas.openxmlformats.org/officeDocument/2006/relationships" xmlns:a="http://schemas.openxmlformats.org/drawingml/2006/main" r:embed="R27dbc1128e104001"/>
+          <a:blip xmlns:r="http://schemas.openxmlformats.org/officeDocument/2006/relationships" xmlns:a="http://schemas.openxmlformats.org/drawingml/2006/main" r:embed="Rc29015e1b8974c5c"/>
           <a:stretch xmlns:a="http://schemas.openxmlformats.org/drawingml/2006/main">
             <a:fillRect l="0" t="0" r="0" b="0"/>
           </a:stretch>
@@ -8335,7 +8335,7 @@
           <p:nvPr/>
         </p:nvPicPr>
         <p:blipFill>
-          <a:blip xmlns:r="http://schemas.openxmlformats.org/officeDocument/2006/relationships" xmlns:a="http://schemas.openxmlformats.org/drawingml/2006/main" r:embed="R0c76a1a67e024da8"/>
+          <a:blip xmlns:r="http://schemas.openxmlformats.org/officeDocument/2006/relationships" xmlns:a="http://schemas.openxmlformats.org/drawingml/2006/main" r:embed="Rbaf582b2a0e140cc"/>
           <a:stretch xmlns:a="http://schemas.openxmlformats.org/drawingml/2006/main">
             <a:fillRect l="0" t="0" r="0" b="0"/>
           </a:stretch>
@@ -8499,7 +8499,7 @@
           <p:nvPr/>
         </p:nvPicPr>
         <p:blipFill>
-          <a:blip xmlns:r="http://schemas.openxmlformats.org/officeDocument/2006/relationships" xmlns:a="http://schemas.openxmlformats.org/drawingml/2006/main" r:embed="R044cd2cc2c0c4f31"/>
+          <a:blip xmlns:r="http://schemas.openxmlformats.org/officeDocument/2006/relationships" xmlns:a="http://schemas.openxmlformats.org/drawingml/2006/main" r:embed="R8d01c506c7c3405c"/>
           <a:stretch xmlns:a="http://schemas.openxmlformats.org/drawingml/2006/main">
             <a:fillRect l="0" t="0" r="0" b="0"/>
           </a:stretch>
@@ -8663,7 +8663,7 @@
           <p:nvPr/>
         </p:nvPicPr>
         <p:blipFill>
-          <a:blip xmlns:r="http://schemas.openxmlformats.org/officeDocument/2006/relationships" xmlns:a="http://schemas.openxmlformats.org/drawingml/2006/main" r:embed="R74a6fa4d54f14dd0"/>
+          <a:blip xmlns:r="http://schemas.openxmlformats.org/officeDocument/2006/relationships" xmlns:a="http://schemas.openxmlformats.org/drawingml/2006/main" r:embed="R120b3cb0938747c7"/>
           <a:stretch xmlns:a="http://schemas.openxmlformats.org/drawingml/2006/main">
             <a:fillRect l="0" t="0" r="0" b="0"/>
           </a:stretch>
@@ -8718,7 +8718,7 @@
                 <a:ea typeface="Calibri"/>
                 <a:cs typeface="Calibri"/>
               </a:rPr>
-              <a:t>8-tool allow-list · 2 turns · 6s timeout · idempotency · replay · kill switch</a:t>
+              <a:t>8-tool allow-list · 2 turns · 6s timeout · labelled fallback · replay · kill switch</a:t>
             </a:r>
             <a:endParaRPr sz="1050"/>
           </a:p>
@@ -8935,7 +8935,7 @@
           <p:nvPr/>
         </p:nvPicPr>
         <p:blipFill>
-          <a:blip xmlns:r="http://schemas.openxmlformats.org/officeDocument/2006/relationships" xmlns:a="http://schemas.openxmlformats.org/drawingml/2006/main" r:embed="Reae9315ee7524902"/>
+          <a:blip xmlns:r="http://schemas.openxmlformats.org/officeDocument/2006/relationships" xmlns:a="http://schemas.openxmlformats.org/drawingml/2006/main" r:embed="R5ce79a59c6304fe2"/>
           <a:stretch xmlns:a="http://schemas.openxmlformats.org/drawingml/2006/main">
             <a:fillRect l="0" t="0" r="0" b="0"/>
           </a:stretch>
@@ -9245,7 +9245,7 @@
           <p:nvPr/>
         </p:nvPicPr>
         <p:blipFill>
-          <a:blip xmlns:r="http://schemas.openxmlformats.org/officeDocument/2006/relationships" xmlns:a="http://schemas.openxmlformats.org/drawingml/2006/main" r:embed="R2651ae2fd4cb44f5"/>
+          <a:blip xmlns:r="http://schemas.openxmlformats.org/officeDocument/2006/relationships" xmlns:a="http://schemas.openxmlformats.org/drawingml/2006/main" r:embed="R59a486e36d72483e"/>
           <a:stretch xmlns:a="http://schemas.openxmlformats.org/drawingml/2006/main">
             <a:fillRect l="0" t="0" r="0" b="0"/>
           </a:stretch>
@@ -9742,7 +9742,7 @@
           <p:nvPr/>
         </p:nvPicPr>
         <p:blipFill>
-          <a:blip xmlns:r="http://schemas.openxmlformats.org/officeDocument/2006/relationships" xmlns:a="http://schemas.openxmlformats.org/drawingml/2006/main" r:embed="R4e7f5479601742ff"/>
+          <a:blip xmlns:r="http://schemas.openxmlformats.org/officeDocument/2006/relationships" xmlns:a="http://schemas.openxmlformats.org/drawingml/2006/main" r:embed="Re8cc1c1bd2644035"/>
           <a:stretch xmlns:a="http://schemas.openxmlformats.org/drawingml/2006/main">
             <a:fillRect l="0" t="0" r="0" b="0"/>
           </a:stretch>
@@ -10019,7 +10019,7 @@
           <p:nvPr/>
         </p:nvPicPr>
         <p:blipFill>
-          <a:blip xmlns:r="http://schemas.openxmlformats.org/officeDocument/2006/relationships" xmlns:a="http://schemas.openxmlformats.org/drawingml/2006/main" r:embed="R6e78f9e04f314c03"/>
+          <a:blip xmlns:r="http://schemas.openxmlformats.org/officeDocument/2006/relationships" xmlns:a="http://schemas.openxmlformats.org/drawingml/2006/main" r:embed="R9a0c5f9b2caa4a66"/>
           <a:stretch xmlns:a="http://schemas.openxmlformats.org/drawingml/2006/main">
             <a:fillRect l="0" t="0" r="0" b="0"/>
           </a:stretch>
@@ -10296,7 +10296,7 @@
           <p:nvPr/>
         </p:nvPicPr>
         <p:blipFill>
-          <a:blip xmlns:r="http://schemas.openxmlformats.org/officeDocument/2006/relationships" xmlns:a="http://schemas.openxmlformats.org/drawingml/2006/main" r:embed="Rd3e228ed77b84fa4"/>
+          <a:blip xmlns:r="http://schemas.openxmlformats.org/officeDocument/2006/relationships" xmlns:a="http://schemas.openxmlformats.org/drawingml/2006/main" r:embed="R1b5054a7a6784883"/>
           <a:stretch xmlns:a="http://schemas.openxmlformats.org/drawingml/2006/main">
             <a:fillRect l="0" t="0" r="0" b="0"/>
           </a:stretch>
@@ -10573,7 +10573,7 @@
           <p:nvPr/>
         </p:nvPicPr>
         <p:blipFill>
-          <a:blip xmlns:r="http://schemas.openxmlformats.org/officeDocument/2006/relationships" xmlns:a="http://schemas.openxmlformats.org/drawingml/2006/main" r:embed="R90ef447882064f0d"/>
+          <a:blip xmlns:r="http://schemas.openxmlformats.org/officeDocument/2006/relationships" xmlns:a="http://schemas.openxmlformats.org/drawingml/2006/main" r:embed="Ra01a21b8f5cd4e51"/>
           <a:stretch xmlns:a="http://schemas.openxmlformats.org/drawingml/2006/main">
             <a:fillRect l="0" t="0" r="0" b="0"/>
           </a:stretch>

</xml_diff>